<commit_message>
fix slide pagination and TeX macro rendering
</commit_message>
<xml_diff>
--- a/book/slides/pptx/ch02-linear-list.pptx
+++ b/book/slides/pptx/ch02-linear-list.pptx
@@ -755,7 +755,7 @@
 </p:notes>
 </file>
 
-<file path=ppt/notesSlides/notesSlide20.xml><?xml version="1.0" encoding="utf-8"?>
+<file path=ppt/notesSlides/notesSlide21.xml><?xml version="1.0" encoding="utf-8"?>
 <p:notes xmlns:a="http://schemas.openxmlformats.org/drawingml/2006/main" xmlns:r="http://schemas.openxmlformats.org/officeDocument/2006/relationships" xmlns:p="http://schemas.openxmlformats.org/presentationml/2006/main">
   <p:cSld>
     <p:spTree>
@@ -9802,7 +9802,7 @@
                 <a:ea typeface="Noto Sans CJK SC"/>
                 <a:cs typeface="Segoe UI"/>
               </a:rPr>
-              <a:t>双链表的删除：两侧都要改（续）</a:t>
+              <a:t>双链表的删除：两侧都要改</a:t>
             </a:r>
           </a:p>
         </p:txBody>

</xml_diff>